<commit_message>
Deck: simplify Round 3 outcomes and rewrite limits slide
Round 3 now shows two outcomes (consensus, fallback to the cheapest valid plan,
human decides). Limits slide is limit -> next step, with the closing line on
three short lines.

Co-Authored-By: Claude Sonnet 5.5 <noreply@anthropic.com>
</commit_message>
<xml_diff>
--- a/pitch.pptx
+++ b/pitch.pptx
@@ -601,7 +601,7 @@
           <a:p>
             <a:r>
               <a:rPr lang="en-US" dirty="0"/>
-              <a:t>Round 3 is accept or reject only. All three accept: consensus. Any reject: the deterministic non-AI fallback picks the cheapest plan that passes every rule. If no plan passes, the system recommends cancellation and never applies it on its own. The human duty manager always decides.</a:t>
+              <a:t>Round 3 is accept or reject only. All three accept: consensus. Any reject: the deterministic non-AI fallback picks the cheapest plan that passes every hard rule. The human duty manager always decides. If asked: when no plan at all passes every hard rule, the system says so and recommends cancellation to the human; it never applies it on its own.</a:t>
             </a:r>
             <a:endParaRPr lang="en-US" dirty="0"/>
           </a:p>
@@ -777,7 +777,7 @@
           <a:p>
             <a:r>
               <a:rPr lang="en-US" dirty="0"/>
-              <a:t>Be candid. Synthetic inputs are labelled. Only 5 live flights so far. In rounds 1 and 2 the plans and scores are computed from each agent's own rules in code; the live Claude agents vote and explain in round 3. Next: live Claude scoring in rounds 1 and 2, a batch of about 30 flights against the fallback baseline, real gate and crew feeds. Close on the line.</a:t>
+              <a:t>Be candid and brief. Gates and crew are synthetic and labelled; real feeds come next. Five live flights so far; next is a batch of about 30 against the fallback baseline. Today the live Claude agents vote and explain in round 3, while rounds 1 and 2 are scored from each agent's own rules in code; live Claude scoring in rounds 1 and 2 is next. Close on the three lines.</a:t>
             </a:r>
             <a:endParaRPr lang="en-US" dirty="0"/>
           </a:p>
@@ -1902,7 +1902,7 @@
         <p:spPr>
           <a:xfrm>
             <a:off x="640080" y="2377440"/>
-            <a:ext cx="4937760" cy="548640"/>
+            <a:ext cx="5029200" cy="731520"/>
           </a:xfrm>
           <a:prstGeom prst="rect">
             <a:avLst/>
@@ -1918,7 +1918,7 @@
               <a:buNone/>
             </a:pPr>
             <a:r>
-              <a:rPr lang="en-US" sz="2600" dirty="0">
+              <a:rPr lang="en-US" sz="2400" dirty="0">
                 <a:solidFill>
                   <a:srgbClr val="F5A623"/>
                 </a:solidFill>
@@ -1928,7 +1928,7 @@
               </a:rPr>
               <a:t>Three agents. One safe plan.</a:t>
             </a:r>
-            <a:endParaRPr lang="en-US" sz="2600" dirty="0"/>
+            <a:endParaRPr lang="en-US" sz="2400" dirty="0"/>
           </a:p>
         </p:txBody>
       </p:sp>
@@ -2594,12 +2594,12 @@
         </p:nvSpPr>
         <p:spPr>
           <a:xfrm>
-            <a:off x="3657600" y="1234440"/>
-            <a:ext cx="4937760" cy="777240"/>
+            <a:off x="3657600" y="1463040"/>
+            <a:ext cx="4937760" cy="1005840"/>
           </a:xfrm>
           <a:prstGeom prst="roundRect">
             <a:avLst>
-              <a:gd name="adj" fmla="val 14118"/>
+              <a:gd name="adj" fmla="val 10909"/>
             </a:avLst>
           </a:prstGeom>
           <a:solidFill>
@@ -2621,8 +2621,8 @@
         </p:nvSpPr>
         <p:spPr>
           <a:xfrm>
-            <a:off x="3886200" y="1234440"/>
-            <a:ext cx="4572000" cy="777240"/>
+            <a:off x="3886200" y="1463040"/>
+            <a:ext cx="4526280" cy="1005840"/>
           </a:xfrm>
           <a:prstGeom prst="rect">
             <a:avLst/>
@@ -2638,7 +2638,7 @@
               <a:buNone/>
             </a:pPr>
             <a:r>
-              <a:rPr lang="en-US" sz="1900" b="1" dirty="0">
+              <a:rPr lang="en-US" sz="2000" b="1" dirty="0">
                 <a:solidFill>
                   <a:srgbClr val="FFFFFF"/>
                 </a:solidFill>
@@ -2648,7 +2648,7 @@
               </a:rPr>
               <a:t>Consensus</a:t>
             </a:r>
-            <a:endParaRPr lang="en-US" sz="1900" dirty="0"/>
+            <a:endParaRPr lang="en-US" sz="2000" dirty="0"/>
           </a:p>
           <a:p>
             <a:pPr indent="0" marL="0">
@@ -2665,7 +2665,7 @@
               </a:rPr>
               <a:t>All 3 accept: the plan goes to the human</a:t>
             </a:r>
-            <a:endParaRPr lang="en-US" sz="1900" dirty="0"/>
+            <a:endParaRPr lang="en-US" sz="2000" dirty="0"/>
           </a:p>
         </p:txBody>
       </p:sp>
@@ -2677,8 +2677,8 @@
         </p:nvSpPr>
         <p:spPr>
           <a:xfrm flipV="1">
-            <a:off x="2743200" y="1623060"/>
-            <a:ext cx="914400" cy="1165860"/>
+            <a:off x="2743200" y="1965960"/>
+            <a:ext cx="914400" cy="822960"/>
           </a:xfrm>
           <a:prstGeom prst="line">
             <a:avLst/>
@@ -2701,12 +2701,12 @@
         </p:nvSpPr>
         <p:spPr>
           <a:xfrm>
-            <a:off x="3657600" y="2423160"/>
-            <a:ext cx="4937760" cy="777240"/>
+            <a:off x="3657600" y="2926080"/>
+            <a:ext cx="4937760" cy="1005840"/>
           </a:xfrm>
           <a:prstGeom prst="roundRect">
             <a:avLst>
-              <a:gd name="adj" fmla="val 14118"/>
+              <a:gd name="adj" fmla="val 10909"/>
             </a:avLst>
           </a:prstGeom>
           <a:solidFill>
@@ -2728,8 +2728,8 @@
         </p:nvSpPr>
         <p:spPr>
           <a:xfrm>
-            <a:off x="3886200" y="2423160"/>
-            <a:ext cx="4572000" cy="777240"/>
+            <a:off x="3886200" y="2926080"/>
+            <a:ext cx="4526280" cy="1005840"/>
           </a:xfrm>
           <a:prstGeom prst="rect">
             <a:avLst/>
@@ -2745,7 +2745,7 @@
               <a:buNone/>
             </a:pPr>
             <a:r>
-              <a:rPr lang="en-US" sz="1900" b="1" dirty="0">
+              <a:rPr lang="en-US" sz="2000" b="1" dirty="0">
                 <a:solidFill>
                   <a:srgbClr val="0F1B2D"/>
                 </a:solidFill>
@@ -2755,7 +2755,7 @@
               </a:rPr>
               <a:t>Fallback</a:t>
             </a:r>
-            <a:endParaRPr lang="en-US" sz="1900" dirty="0"/>
+            <a:endParaRPr lang="en-US" sz="2000" dirty="0"/>
           </a:p>
           <a:p>
             <a:pPr indent="0" marL="0">
@@ -2770,9 +2770,9 @@
                 <a:ea typeface="Calibri" pitchFamily="34" charset="-122"/>
                 <a:cs typeface="Calibri" pitchFamily="34" charset="-120"/>
               </a:rPr>
-              <a:t>Any reject: cheapest plan that passes every rule</a:t>
-            </a:r>
-            <a:endParaRPr lang="en-US" sz="1900" dirty="0"/>
+              <a:t>Any reject: cheapest plan that passes every rule, then the human decides</a:t>
+            </a:r>
+            <a:endParaRPr lang="en-US" sz="2000" dirty="0"/>
           </a:p>
         </p:txBody>
       </p:sp>
@@ -2785,114 +2785,7 @@
         <p:spPr>
           <a:xfrm>
             <a:off x="2743200" y="2788920"/>
-            <a:ext cx="914400" cy="22860"/>
-          </a:xfrm>
-          <a:prstGeom prst="line">
-            <a:avLst/>
-          </a:prstGeom>
-          <a:noFill/>
-          <a:ln w="19050">
-            <a:solidFill>
-              <a:srgbClr val="5B6770"/>
-            </a:solidFill>
-            <a:prstDash val="solid"/>
-            <a:tailEnd type="triangle"/>
-          </a:ln>
-        </p:spPr>
-      </p:sp>
-      <p:sp>
-        <p:nvSpPr>
-          <p:cNvPr id="17" name="Shape 15"/>
-          <p:cNvSpPr/>
-          <p:nvPr/>
-        </p:nvSpPr>
-        <p:spPr>
-          <a:xfrm>
-            <a:off x="3657600" y="3611880"/>
-            <a:ext cx="4937760" cy="777240"/>
-          </a:xfrm>
-          <a:prstGeom prst="roundRect">
-            <a:avLst>
-              <a:gd name="adj" fmla="val 14118"/>
-            </a:avLst>
-          </a:prstGeom>
-          <a:solidFill>
-            <a:srgbClr val="B03A2E"/>
-          </a:solidFill>
-          <a:ln w="12700">
-            <a:solidFill>
-              <a:srgbClr val="B03A2E"/>
-            </a:solidFill>
-            <a:prstDash val="solid"/>
-          </a:ln>
-        </p:spPr>
-      </p:sp>
-      <p:sp>
-        <p:nvSpPr>
-          <p:cNvPr id="18" name="Text 16"/>
-          <p:cNvSpPr/>
-          <p:nvPr/>
-        </p:nvSpPr>
-        <p:spPr>
-          <a:xfrm>
-            <a:off x="3886200" y="3611880"/>
-            <a:ext cx="4572000" cy="777240"/>
-          </a:xfrm>
-          <a:prstGeom prst="rect">
-            <a:avLst/>
-          </a:prstGeom>
-          <a:noFill/>
-          <a:ln/>
-        </p:spPr>
-        <p:txBody>
-          <a:bodyPr wrap="square" lIns="0" tIns="0" rIns="0" bIns="0" rtlCol="0" anchor="ctr"/>
-          <a:lstStyle/>
-          <a:p>
-            <a:pPr indent="0" marL="0">
-              <a:buNone/>
-            </a:pPr>
-            <a:r>
-              <a:rPr lang="en-US" sz="1900" b="1" dirty="0">
-                <a:solidFill>
-                  <a:srgbClr val="FFFFFF"/>
-                </a:solidFill>
-                <a:latin typeface="Calibri" pitchFamily="34" charset="0"/>
-                <a:ea typeface="Calibri" pitchFamily="34" charset="-122"/>
-                <a:cs typeface="Calibri" pitchFamily="34" charset="-120"/>
-              </a:rPr>
-              <a:t>No safe plan</a:t>
-            </a:r>
-            <a:endParaRPr lang="en-US" sz="1900" dirty="0"/>
-          </a:p>
-          <a:p>
-            <a:pPr indent="0" marL="0">
-              <a:buNone/>
-            </a:pPr>
-            <a:r>
-              <a:rPr lang="en-US" sz="1400" dirty="0">
-                <a:solidFill>
-                  <a:srgbClr val="FFFFFF"/>
-                </a:solidFill>
-                <a:latin typeface="Calibri" pitchFamily="34" charset="0"/>
-                <a:ea typeface="Calibri" pitchFamily="34" charset="-122"/>
-                <a:cs typeface="Calibri" pitchFamily="34" charset="-120"/>
-              </a:rPr>
-              <a:t>Recommend cancellation; the human decides</a:t>
-            </a:r>
-            <a:endParaRPr lang="en-US" sz="1900" dirty="0"/>
-          </a:p>
-        </p:txBody>
-      </p:sp>
-      <p:sp>
-        <p:nvSpPr>
-          <p:cNvPr id="19" name="Shape 17"/>
-          <p:cNvSpPr/>
-          <p:nvPr/>
-        </p:nvSpPr>
-        <p:spPr>
-          <a:xfrm>
-            <a:off x="2743200" y="2788920"/>
-            <a:ext cx="914400" cy="1211580"/>
+            <a:ext cx="914400" cy="640080"/>
           </a:xfrm>
           <a:prstGeom prst="line">
             <a:avLst/>
@@ -3641,7 +3534,7 @@
                 <a:ea typeface="Cambria" pitchFamily="34" charset="-122"/>
                 <a:cs typeface="Cambria" pitchFamily="34" charset="-120"/>
               </a:rPr>
-              <a:t>Honest limits</a:t>
+              <a:t>Limits and next steps</a:t>
             </a:r>
             <a:endParaRPr lang="en-US" sz="2800" dirty="0"/>
           </a:p>
@@ -3655,7 +3548,7 @@
         </p:nvSpPr>
         <p:spPr>
           <a:xfrm>
-            <a:off x="640080" y="1280160"/>
+            <a:off x="640080" y="1188720"/>
             <a:ext cx="457200" cy="457200"/>
           </a:xfrm>
           <a:prstGeom prst="ellipse">
@@ -3680,7 +3573,7 @@
         </p:nvSpPr>
         <p:spPr>
           <a:xfrm>
-            <a:off x="640080" y="1280160"/>
+            <a:off x="640080" y="1188720"/>
             <a:ext cx="457200" cy="457200"/>
           </a:xfrm>
           <a:prstGeom prst="rect">
@@ -3719,8 +3612,8 @@
         </p:nvSpPr>
         <p:spPr>
           <a:xfrm>
-            <a:off x="1371600" y="1188720"/>
-            <a:ext cx="7223760" cy="640080"/>
+            <a:off x="1371600" y="1143000"/>
+            <a:ext cx="7223760" cy="548640"/>
           </a:xfrm>
           <a:prstGeom prst="rect">
             <a:avLst/>
@@ -3744,7 +3637,35 @@
                 <a:ea typeface="Calibri" pitchFamily="34" charset="-122"/>
                 <a:cs typeface="Calibri" pitchFamily="34" charset="-120"/>
               </a:rPr>
-              <a:t>Gates, crew and connections are synthetic, and labelled</a:t>
+              <a:t>Synthetic gates and crew (labelled)</a:t>
+            </a:r>
+            <a:pPr indent="0" marL="0">
+              <a:buNone/>
+            </a:pPr>
+            <a:r>
+              <a:rPr lang="en-US" sz="1600" b="1" dirty="0">
+                <a:solidFill>
+                  <a:srgbClr val="F5A623"/>
+                </a:solidFill>
+                <a:latin typeface="Calibri" pitchFamily="34" charset="0"/>
+                <a:ea typeface="Calibri" pitchFamily="34" charset="-122"/>
+                <a:cs typeface="Calibri" pitchFamily="34" charset="-120"/>
+              </a:rPr>
+              <a:t>   →   </a:t>
+            </a:r>
+            <a:pPr indent="0" marL="0">
+              <a:buNone/>
+            </a:pPr>
+            <a:r>
+              <a:rPr lang="en-US" sz="1600" dirty="0">
+                <a:solidFill>
+                  <a:srgbClr val="C9D3DF"/>
+                </a:solidFill>
+                <a:latin typeface="Calibri" pitchFamily="34" charset="0"/>
+                <a:ea typeface="Calibri" pitchFamily="34" charset="-122"/>
+                <a:cs typeface="Calibri" pitchFamily="34" charset="-120"/>
+              </a:rPr>
+              <a:t>real feeds</a:t>
             </a:r>
             <a:endParaRPr lang="en-US" sz="1600" dirty="0"/>
           </a:p>
@@ -3758,7 +3679,7 @@
         </p:nvSpPr>
         <p:spPr>
           <a:xfrm>
-            <a:off x="640080" y="2057400"/>
+            <a:off x="640080" y="1874520"/>
             <a:ext cx="457200" cy="457200"/>
           </a:xfrm>
           <a:prstGeom prst="ellipse">
@@ -3783,7 +3704,7 @@
         </p:nvSpPr>
         <p:spPr>
           <a:xfrm>
-            <a:off x="640080" y="2057400"/>
+            <a:off x="640080" y="1874520"/>
             <a:ext cx="457200" cy="457200"/>
           </a:xfrm>
           <a:prstGeom prst="rect">
@@ -3822,8 +3743,8 @@
         </p:nvSpPr>
         <p:spPr>
           <a:xfrm>
-            <a:off x="1371600" y="1965960"/>
-            <a:ext cx="7223760" cy="640080"/>
+            <a:off x="1371600" y="1828800"/>
+            <a:ext cx="7223760" cy="548640"/>
           </a:xfrm>
           <a:prstGeom prst="rect">
             <a:avLst/>
@@ -3847,7 +3768,35 @@
                 <a:ea typeface="Calibri" pitchFamily="34" charset="-122"/>
                 <a:cs typeface="Calibri" pitchFamily="34" charset="-120"/>
               </a:rPr>
-              <a:t>5 live flights tested, not a batch of 30 yet</a:t>
+              <a:t>5 live flights tested</a:t>
+            </a:r>
+            <a:pPr indent="0" marL="0">
+              <a:buNone/>
+            </a:pPr>
+            <a:r>
+              <a:rPr lang="en-US" sz="1600" b="1" dirty="0">
+                <a:solidFill>
+                  <a:srgbClr val="F5A623"/>
+                </a:solidFill>
+                <a:latin typeface="Calibri" pitchFamily="34" charset="0"/>
+                <a:ea typeface="Calibri" pitchFamily="34" charset="-122"/>
+                <a:cs typeface="Calibri" pitchFamily="34" charset="-120"/>
+              </a:rPr>
+              <a:t>   →   </a:t>
+            </a:r>
+            <a:pPr indent="0" marL="0">
+              <a:buNone/>
+            </a:pPr>
+            <a:r>
+              <a:rPr lang="en-US" sz="1600" dirty="0">
+                <a:solidFill>
+                  <a:srgbClr val="C9D3DF"/>
+                </a:solidFill>
+                <a:latin typeface="Calibri" pitchFamily="34" charset="0"/>
+                <a:ea typeface="Calibri" pitchFamily="34" charset="-122"/>
+                <a:cs typeface="Calibri" pitchFamily="34" charset="-120"/>
+              </a:rPr>
+              <a:t>batch of 30 vs the fallback baseline</a:t>
             </a:r>
             <a:endParaRPr lang="en-US" sz="1600" dirty="0"/>
           </a:p>
@@ -3861,7 +3810,7 @@
         </p:nvSpPr>
         <p:spPr>
           <a:xfrm>
-            <a:off x="640080" y="2834640"/>
+            <a:off x="640080" y="2560320"/>
             <a:ext cx="457200" cy="457200"/>
           </a:xfrm>
           <a:prstGeom prst="ellipse">
@@ -3886,7 +3835,7 @@
         </p:nvSpPr>
         <p:spPr>
           <a:xfrm>
-            <a:off x="640080" y="2834640"/>
+            <a:off x="640080" y="2560320"/>
             <a:ext cx="457200" cy="457200"/>
           </a:xfrm>
           <a:prstGeom prst="rect">
@@ -3925,8 +3874,8 @@
         </p:nvSpPr>
         <p:spPr>
           <a:xfrm>
-            <a:off x="1371600" y="2743200"/>
-            <a:ext cx="7223760" cy="640080"/>
+            <a:off x="1371600" y="2514600"/>
+            <a:ext cx="7223760" cy="548640"/>
           </a:xfrm>
           <a:prstGeom prst="rect">
             <a:avLst/>
@@ -3950,7 +3899,35 @@
                 <a:ea typeface="Calibri" pitchFamily="34" charset="-122"/>
                 <a:cs typeface="Calibri" pitchFamily="34" charset="-120"/>
               </a:rPr>
-              <a:t>Rounds 1 and 2 scores come from each agent's rules in code; Claude votes and explains in round 3</a:t>
+              <a:t>Claude votes in round 3</a:t>
+            </a:r>
+            <a:pPr indent="0" marL="0">
+              <a:buNone/>
+            </a:pPr>
+            <a:r>
+              <a:rPr lang="en-US" sz="1600" b="1" dirty="0">
+                <a:solidFill>
+                  <a:srgbClr val="F5A623"/>
+                </a:solidFill>
+                <a:latin typeface="Calibri" pitchFamily="34" charset="0"/>
+                <a:ea typeface="Calibri" pitchFamily="34" charset="-122"/>
+                <a:cs typeface="Calibri" pitchFamily="34" charset="-120"/>
+              </a:rPr>
+              <a:t>   →   </a:t>
+            </a:r>
+            <a:pPr indent="0" marL="0">
+              <a:buNone/>
+            </a:pPr>
+            <a:r>
+              <a:rPr lang="en-US" sz="1600" dirty="0">
+                <a:solidFill>
+                  <a:srgbClr val="C9D3DF"/>
+                </a:solidFill>
+                <a:latin typeface="Calibri" pitchFamily="34" charset="0"/>
+                <a:ea typeface="Calibri" pitchFamily="34" charset="-122"/>
+                <a:cs typeface="Calibri" pitchFamily="34" charset="-120"/>
+              </a:rPr>
+              <a:t>live Claude scoring in rounds 1 and 2</a:t>
             </a:r>
             <a:endParaRPr lang="en-US" sz="1600" dirty="0"/>
           </a:p>
@@ -3964,8 +3941,8 @@
         </p:nvSpPr>
         <p:spPr>
           <a:xfrm>
-            <a:off x="548640" y="3611880"/>
-            <a:ext cx="8046720" cy="822960"/>
+            <a:off x="548640" y="3246120"/>
+            <a:ext cx="8046720" cy="1280160"/>
           </a:xfrm>
           <a:prstGeom prst="rect">
             <a:avLst/>
@@ -3989,10 +3966,44 @@
                 <a:ea typeface="Cambria" pitchFamily="34" charset="-122"/>
                 <a:cs typeface="Cambria" pitchFamily="34" charset="-120"/>
               </a:rPr>
-              <a:t>Code owns safety. Agents own the trade-offs. Humans decide.</a:t>
+              <a:t>Code owns safety.</a:t>
             </a:r>
             <a:endParaRPr lang="en-US" sz="2600" dirty="0"/>
           </a:p>
+          <a:p>
+            <a:pPr indent="0" marL="0">
+              <a:buNone/>
+            </a:pPr>
+            <a:r>
+              <a:rPr lang="en-US" sz="2600" b="1" dirty="0">
+                <a:solidFill>
+                  <a:srgbClr val="F5A623"/>
+                </a:solidFill>
+                <a:latin typeface="Cambria" pitchFamily="34" charset="0"/>
+                <a:ea typeface="Cambria" pitchFamily="34" charset="-122"/>
+                <a:cs typeface="Cambria" pitchFamily="34" charset="-120"/>
+              </a:rPr>
+              <a:t>Agents own the trade-offs.</a:t>
+            </a:r>
+            <a:endParaRPr lang="en-US" sz="2600" dirty="0"/>
+          </a:p>
+          <a:p>
+            <a:pPr indent="0" marL="0">
+              <a:buNone/>
+            </a:pPr>
+            <a:r>
+              <a:rPr lang="en-US" sz="2600" b="1" dirty="0">
+                <a:solidFill>
+                  <a:srgbClr val="F5A623"/>
+                </a:solidFill>
+                <a:latin typeface="Cambria" pitchFamily="34" charset="0"/>
+                <a:ea typeface="Cambria" pitchFamily="34" charset="-122"/>
+                <a:cs typeface="Cambria" pitchFamily="34" charset="-120"/>
+              </a:rPr>
+              <a:t>Humans decide.</a:t>
+            </a:r>
+            <a:endParaRPr lang="en-US" sz="2600" dirty="0"/>
+          </a:p>
         </p:txBody>
       </p:sp>
       <p:sp>
@@ -4003,8 +4014,8 @@
         </p:nvSpPr>
         <p:spPr>
           <a:xfrm>
-            <a:off x="548640" y="4526280"/>
-            <a:ext cx="8046720" cy="320040"/>
+            <a:off x="548640" y="4617720"/>
+            <a:ext cx="8046720" cy="274320"/>
           </a:xfrm>
           <a:prstGeom prst="rect">
             <a:avLst/>
@@ -7436,7 +7447,7 @@
         <p:spPr>
           <a:xfrm>
             <a:off x="777240" y="2697480"/>
-            <a:ext cx="1920240" cy="548640"/>
+            <a:ext cx="1920240" cy="594360"/>
           </a:xfrm>
           <a:prstGeom prst="rect">
             <a:avLst/>
@@ -7452,7 +7463,7 @@
               <a:buNone/>
             </a:pPr>
             <a:r>
-              <a:rPr lang="en-US" sz="1400" dirty="0">
+              <a:rPr lang="en-US" sz="1300" dirty="0">
                 <a:solidFill>
                   <a:srgbClr val="5B6770"/>
                 </a:solidFill>
@@ -7462,7 +7473,7 @@
               </a:rPr>
               <a:t>Each agent sends 10 plans, best to worst</a:t>
             </a:r>
-            <a:endParaRPr lang="en-US" sz="1400" dirty="0"/>
+            <a:endParaRPr lang="en-US" sz="1300" dirty="0"/>
           </a:p>
         </p:txBody>
       </p:sp>
@@ -7629,7 +7640,7 @@
         <p:spPr>
           <a:xfrm>
             <a:off x="3611880" y="2697480"/>
-            <a:ext cx="1920240" cy="548640"/>
+            <a:ext cx="1920240" cy="594360"/>
           </a:xfrm>
           <a:prstGeom prst="rect">
             <a:avLst/>
@@ -7645,7 +7656,7 @@
               <a:buNone/>
             </a:pPr>
             <a:r>
-              <a:rPr lang="en-US" sz="1400" dirty="0">
+              <a:rPr lang="en-US" sz="1300" dirty="0">
                 <a:solidFill>
                   <a:srgbClr val="5B6770"/>
                 </a:solidFill>
@@ -7655,7 +7666,7 @@
               </a:rPr>
               <a:t>Every agent scores the whole shortlist</a:t>
             </a:r>
-            <a:endParaRPr lang="en-US" sz="1400" dirty="0"/>
+            <a:endParaRPr lang="en-US" sz="1300" dirty="0"/>
           </a:p>
         </p:txBody>
       </p:sp>
@@ -7822,7 +7833,7 @@
         <p:spPr>
           <a:xfrm>
             <a:off x="6446520" y="2697480"/>
-            <a:ext cx="1920240" cy="548640"/>
+            <a:ext cx="1920240" cy="594360"/>
           </a:xfrm>
           <a:prstGeom prst="rect">
             <a:avLst/>
@@ -7838,7 +7849,7 @@
               <a:buNone/>
             </a:pPr>
             <a:r>
-              <a:rPr lang="en-US" sz="1400" dirty="0">
+              <a:rPr lang="en-US" sz="1300" dirty="0">
                 <a:solidFill>
                   <a:srgbClr val="5B6770"/>
                 </a:solidFill>
@@ -7848,7 +7859,7 @@
               </a:rPr>
               <a:t>Accept or reject the picked plan</a:t>
             </a:r>
-            <a:endParaRPr lang="en-US" sz="1400" dirty="0"/>
+            <a:endParaRPr lang="en-US" sz="1300" dirty="0"/>
           </a:p>
         </p:txBody>
       </p:sp>

</xml_diff>

<commit_message>
Add 30-flight batch evaluation and update the deck with its results
mediator/eval_batch.py runs 30 real DFW disruptions live and compares the
agents' plan with the fallback baseline (26/30 consensus, 0 unsafe plans,
agents +10% cost vs cheapest valid plan). Results feed the UI Evaluation panel.
Deck: fallback wording on slides 7 and 10, 30-flight results on slide 11,
simplified limits on slide 12.

Co-Authored-By: Claude Sonnet 5.5 <noreply@anthropic.com>
</commit_message>
<xml_diff>
--- a/pitch.pptx
+++ b/pitch.pptx
@@ -689,7 +689,7 @@
           <a:p>
             <a:r>
               <a:rPr lang="en-US" dirty="0"/>
-              <a:t>Live runs on DFW, 24 April 2015: MQ3086, AA36, AA96, AA1480, AA98. All five ran end to end with no errors, and no unsafe plan was ever chosen. MQ3086, AA36 and AA96 reached consensus. For AA1480 and AA98 every proposed plan broke a hard rule (busy gate, crew duty), so the system chose nothing and recommended cancellation to the human. Have that ready if a judge asks where it fails. This is 5 flights, not a batch of 30.</a:t>
+              <a:t>Batch of 30 live runs on real DFW disruptions of 24 April 2015 (15 weather, 15 late aircraft, random sample, seed 7). 26 reached consensus (87%); 3 had a round-3 reject and went to the fallback (cheapest valid plan); 1 had no valid plan at all. 0 errors and 0 unsafe plans chosen: every chosen plan passed the final safety check. Baseline: on the 26 consensus flights the agents' plan averaged $5,858 against $5,327 for the cheapest valid plan (+10%); the agents' plan was as cheap or cheaper on 8 of 26. Be ready to say why: the agents trade some cost for balance across the three parties. That is the reasoning, not something we measured. The MQ3086 card is the worked example from the earlier demo run.</a:t>
             </a:r>
             <a:endParaRPr lang="en-US" dirty="0"/>
           </a:p>
@@ -777,7 +777,7 @@
           <a:p>
             <a:r>
               <a:rPr lang="en-US" dirty="0"/>
-              <a:t>Be candid and brief. Gates and crew are synthetic and labelled; real feeds come next. Five live flights so far; next is a batch of about 30 against the fallback baseline. Today the live Claude agents vote and explain in round 3, while rounds 1 and 2 are scored from each agent's own rules in code; live Claude scoring in rounds 1 and 2 is next. Close on the three lines.</a:t>
+              <a:t>Keep it short. Gates and crew are synthetic and labelled; real feeds come next. One focal flight per scenario today; many flights at once is next. Close on the three lines.</a:t>
             </a:r>
             <a:endParaRPr lang="en-US" dirty="0"/>
           </a:p>
@@ -1481,7 +1481,7 @@
           <a:p>
             <a:r>
               <a:rPr lang="en-US" dirty="0"/>
-              <a:t>Real scores from the DFW demo. Each agent scores every shortlisted plan from 0 to 1 (1 = best for it), floored at 0.05 so no single score is a veto. The pick rule is the Nash bargaining solution from game theory: maximise the product of the parties' utilities, here the three agent scores plus a cost score, with no-deal taken as zero. It rewards plans nobody hates. Adding would pick C3 at 2.05, but ATC scored it 0.05. Multiplying picks C2.</a:t>
+              <a:t>Real scores from the DFW demo. Each agent scores every shortlisted plan from 0 to 1 (1 = best for it), floored at 0.05 so no single score is a veto. Each agent's score is computed by code from its own private rules, so it is reproducible; Claude votes and explains in round 3. The pick rule is the Nash bargaining solution from game theory: maximise the product of the parties' utilities, here the three agent scores plus a cost score, with no-deal taken as zero. It rewards plans nobody hates. Adding would pick C3 at 2.05, but ATC scored it 0.05. Multiplying picks C2.</a:t>
             </a:r>
             <a:endParaRPr lang="en-US" dirty="0"/>
           </a:p>
@@ -2770,7 +2770,7 @@
                 <a:ea typeface="Calibri" pitchFamily="34" charset="-122"/>
                 <a:cs typeface="Calibri" pitchFamily="34" charset="-120"/>
               </a:rPr>
-              <a:t>Any reject: cheapest plan that passes every rule, then the human decides</a:t>
+              <a:t>Any reject: the cheapest plan that passes every rule (same safety checker), then the human decides</a:t>
             </a:r>
             <a:endParaRPr lang="en-US" sz="2000" dirty="0"/>
           </a:p>
@@ -2865,7 +2865,7 @@
                 <a:ea typeface="Cambria" pitchFamily="34" charset="-122"/>
                 <a:cs typeface="Cambria" pitchFamily="34" charset="-120"/>
               </a:rPr>
-              <a:t>Tested live on 5 flights</a:t>
+              <a:t>Tested live on 30 flights</a:t>
             </a:r>
             <a:endParaRPr lang="en-US" sz="2800" dirty="0"/>
           </a:p>
@@ -3175,7 +3175,7 @@
                 <a:ea typeface="Cambria" pitchFamily="34" charset="-122"/>
                 <a:cs typeface="Cambria" pitchFamily="34" charset="-120"/>
               </a:rPr>
-              <a:t>5</a:t>
+              <a:t>30</a:t>
             </a:r>
             <a:endParaRPr lang="en-US" sz="3600" dirty="0"/>
           </a:p>
@@ -3280,7 +3280,7 @@
                 <a:ea typeface="Cambria" pitchFamily="34" charset="-122"/>
                 <a:cs typeface="Cambria" pitchFamily="34" charset="-120"/>
               </a:rPr>
-              <a:t>0</a:t>
+              <a:t>26</a:t>
             </a:r>
             <a:endParaRPr lang="en-US" sz="3600" dirty="0"/>
           </a:p>
@@ -3319,7 +3319,7 @@
                 <a:ea typeface="Calibri" pitchFamily="34" charset="-122"/>
                 <a:cs typeface="Calibri" pitchFamily="34" charset="-120"/>
               </a:rPr>
-              <a:t>errors</a:t>
+              <a:t>reached consensus (87%)</a:t>
             </a:r>
             <a:endParaRPr lang="en-US" sz="1800" dirty="0"/>
           </a:p>
@@ -3438,8 +3438,8 @@
         </p:nvSpPr>
         <p:spPr>
           <a:xfrm>
-            <a:off x="548640" y="4343400"/>
-            <a:ext cx="8046720" cy="411480"/>
+            <a:off x="548640" y="4297680"/>
+            <a:ext cx="8046720" cy="548640"/>
           </a:xfrm>
           <a:prstGeom prst="rect">
             <a:avLst/>
@@ -3455,7 +3455,7 @@
               <a:buNone/>
             </a:pPr>
             <a:r>
-              <a:rPr lang="en-US" sz="1500" b="1" dirty="0">
+              <a:rPr lang="en-US" sz="1400" b="1" dirty="0">
                 <a:solidFill>
                   <a:srgbClr val="0F1B2D"/>
                 </a:solidFill>
@@ -3463,9 +3463,9 @@
                 <a:ea typeface="Calibri" pitchFamily="34" charset="-122"/>
                 <a:cs typeface="Calibri" pitchFamily="34" charset="-120"/>
               </a:rPr>
-              <a:t>Every plan is checked by code before any agent sees it</a:t>
-            </a:r>
-            <a:endParaRPr lang="en-US" sz="1500" dirty="0"/>
+              <a:t>Average cost: agents $5,858 vs cheapest-valid baseline $5,327 (+10%). 0 errors in 30 runs.</a:t>
+            </a:r>
+            <a:endParaRPr lang="en-US" sz="1400" dirty="0"/>
           </a:p>
         </p:txBody>
       </p:sp>
@@ -3548,7 +3548,7 @@
         </p:nvSpPr>
         <p:spPr>
           <a:xfrm>
-            <a:off x="640080" y="1188720"/>
+            <a:off x="640080" y="1280160"/>
             <a:ext cx="457200" cy="457200"/>
           </a:xfrm>
           <a:prstGeom prst="ellipse">
@@ -3573,7 +3573,7 @@
         </p:nvSpPr>
         <p:spPr>
           <a:xfrm>
-            <a:off x="640080" y="1188720"/>
+            <a:off x="640080" y="1280160"/>
             <a:ext cx="457200" cy="457200"/>
           </a:xfrm>
           <a:prstGeom prst="rect">
@@ -3612,7 +3612,7 @@
         </p:nvSpPr>
         <p:spPr>
           <a:xfrm>
-            <a:off x="1371600" y="1143000"/>
+            <a:off x="1371600" y="1234440"/>
             <a:ext cx="7223760" cy="548640"/>
           </a:xfrm>
           <a:prstGeom prst="rect">
@@ -3629,7 +3629,7 @@
               <a:buNone/>
             </a:pPr>
             <a:r>
-              <a:rPr lang="en-US" sz="1600" dirty="0">
+              <a:rPr lang="en-US" sz="1800" dirty="0">
                 <a:solidFill>
                   <a:srgbClr val="FFFFFF"/>
                 </a:solidFill>
@@ -3643,7 +3643,7 @@
               <a:buNone/>
             </a:pPr>
             <a:r>
-              <a:rPr lang="en-US" sz="1600" b="1" dirty="0">
+              <a:rPr lang="en-US" sz="1800" b="1" dirty="0">
                 <a:solidFill>
                   <a:srgbClr val="F5A623"/>
                 </a:solidFill>
@@ -3657,7 +3657,7 @@
               <a:buNone/>
             </a:pPr>
             <a:r>
-              <a:rPr lang="en-US" sz="1600" dirty="0">
+              <a:rPr lang="en-US" sz="1800" dirty="0">
                 <a:solidFill>
                   <a:srgbClr val="C9D3DF"/>
                 </a:solidFill>
@@ -3665,9 +3665,9 @@
                 <a:ea typeface="Calibri" pitchFamily="34" charset="-122"/>
                 <a:cs typeface="Calibri" pitchFamily="34" charset="-120"/>
               </a:rPr>
-              <a:t>real feeds</a:t>
-            </a:r>
-            <a:endParaRPr lang="en-US" sz="1600" dirty="0"/>
+              <a:t>real airport feeds</a:t>
+            </a:r>
+            <a:endParaRPr lang="en-US" sz="1800" dirty="0"/>
           </a:p>
         </p:txBody>
       </p:sp>
@@ -3679,7 +3679,7 @@
         </p:nvSpPr>
         <p:spPr>
           <a:xfrm>
-            <a:off x="640080" y="1874520"/>
+            <a:off x="640080" y="2011680"/>
             <a:ext cx="457200" cy="457200"/>
           </a:xfrm>
           <a:prstGeom prst="ellipse">
@@ -3704,7 +3704,7 @@
         </p:nvSpPr>
         <p:spPr>
           <a:xfrm>
-            <a:off x="640080" y="1874520"/>
+            <a:off x="640080" y="2011680"/>
             <a:ext cx="457200" cy="457200"/>
           </a:xfrm>
           <a:prstGeom prst="rect">
@@ -3743,7 +3743,7 @@
         </p:nvSpPr>
         <p:spPr>
           <a:xfrm>
-            <a:off x="1371600" y="1828800"/>
+            <a:off x="1371600" y="1965960"/>
             <a:ext cx="7223760" cy="548640"/>
           </a:xfrm>
           <a:prstGeom prst="rect">
@@ -3760,7 +3760,7 @@
               <a:buNone/>
             </a:pPr>
             <a:r>
-              <a:rPr lang="en-US" sz="1600" dirty="0">
+              <a:rPr lang="en-US" sz="1800" dirty="0">
                 <a:solidFill>
                   <a:srgbClr val="FFFFFF"/>
                 </a:solidFill>
@@ -3768,13 +3768,13 @@
                 <a:ea typeface="Calibri" pitchFamily="34" charset="-122"/>
                 <a:cs typeface="Calibri" pitchFamily="34" charset="-120"/>
               </a:rPr>
-              <a:t>5 live flights tested</a:t>
+              <a:t>One focal flight per scenario</a:t>
             </a:r>
             <a:pPr indent="0" marL="0">
               <a:buNone/>
             </a:pPr>
             <a:r>
-              <a:rPr lang="en-US" sz="1600" b="1" dirty="0">
+              <a:rPr lang="en-US" sz="1800" b="1" dirty="0">
                 <a:solidFill>
                   <a:srgbClr val="F5A623"/>
                 </a:solidFill>
@@ -3788,7 +3788,7 @@
               <a:buNone/>
             </a:pPr>
             <a:r>
-              <a:rPr lang="en-US" sz="1600" dirty="0">
+              <a:rPr lang="en-US" sz="1800" dirty="0">
                 <a:solidFill>
                   <a:srgbClr val="C9D3DF"/>
                 </a:solidFill>
@@ -3796,47 +3796,22 @@
                 <a:ea typeface="Calibri" pitchFamily="34" charset="-122"/>
                 <a:cs typeface="Calibri" pitchFamily="34" charset="-120"/>
               </a:rPr>
-              <a:t>batch of 30 vs the fallback baseline</a:t>
-            </a:r>
-            <a:endParaRPr lang="en-US" sz="1600" dirty="0"/>
-          </a:p>
-        </p:txBody>
-      </p:sp>
-      <p:sp>
-        <p:nvSpPr>
-          <p:cNvPr id="9" name="Shape 7"/>
-          <p:cNvSpPr/>
-          <p:nvPr/>
-        </p:nvSpPr>
-        <p:spPr>
-          <a:xfrm>
-            <a:off x="640080" y="2560320"/>
-            <a:ext cx="457200" cy="457200"/>
-          </a:xfrm>
-          <a:prstGeom prst="ellipse">
-            <a:avLst/>
-          </a:prstGeom>
-          <a:solidFill>
-            <a:srgbClr val="F5A623"/>
-          </a:solidFill>
-          <a:ln w="12700">
-            <a:solidFill>
-              <a:srgbClr val="F5A623"/>
-            </a:solidFill>
-            <a:prstDash val="solid"/>
-          </a:ln>
-        </p:spPr>
-      </p:sp>
-      <p:sp>
-        <p:nvSpPr>
-          <p:cNvPr id="10" name="Text 8"/>
-          <p:cNvSpPr/>
-          <p:nvPr/>
-        </p:nvSpPr>
-        <p:spPr>
-          <a:xfrm>
-            <a:off x="640080" y="2560320"/>
-            <a:ext cx="457200" cy="457200"/>
+              <a:t>many flights at once</a:t>
+            </a:r>
+            <a:endParaRPr lang="en-US" sz="1800" dirty="0"/>
+          </a:p>
+        </p:txBody>
+      </p:sp>
+      <p:sp>
+        <p:nvSpPr>
+          <p:cNvPr id="9" name="Text 7"/>
+          <p:cNvSpPr/>
+          <p:nvPr/>
+        </p:nvSpPr>
+        <p:spPr>
+          <a:xfrm>
+            <a:off x="548640" y="2926080"/>
+            <a:ext cx="8046720" cy="1463040"/>
           </a:xfrm>
           <a:prstGeom prst="rect">
             <a:avLst/>
@@ -3848,117 +3823,11 @@
           <a:bodyPr wrap="square" lIns="0" tIns="0" rIns="0" bIns="0" rtlCol="0" anchor="ctr"/>
           <a:lstStyle/>
           <a:p>
-            <a:pPr algn="ctr" indent="0" marL="0">
-              <a:buNone/>
-            </a:pPr>
-            <a:r>
-              <a:rPr lang="en-US" sz="1600" b="1" dirty="0">
-                <a:solidFill>
-                  <a:srgbClr val="0F1B2D"/>
-                </a:solidFill>
-                <a:latin typeface="Calibri" pitchFamily="34" charset="0"/>
-                <a:ea typeface="Calibri" pitchFamily="34" charset="-122"/>
-                <a:cs typeface="Calibri" pitchFamily="34" charset="-120"/>
-              </a:rPr>
-              <a:t>3</a:t>
-            </a:r>
-            <a:endParaRPr lang="en-US" sz="1600" dirty="0"/>
-          </a:p>
-        </p:txBody>
-      </p:sp>
-      <p:sp>
-        <p:nvSpPr>
-          <p:cNvPr id="11" name="Text 9"/>
-          <p:cNvSpPr/>
-          <p:nvPr/>
-        </p:nvSpPr>
-        <p:spPr>
-          <a:xfrm>
-            <a:off x="1371600" y="2514600"/>
-            <a:ext cx="7223760" cy="548640"/>
-          </a:xfrm>
-          <a:prstGeom prst="rect">
-            <a:avLst/>
-          </a:prstGeom>
-          <a:noFill/>
-          <a:ln/>
-        </p:spPr>
-        <p:txBody>
-          <a:bodyPr wrap="square" lIns="0" tIns="0" rIns="0" bIns="0" rtlCol="0" anchor="ctr"/>
-          <a:lstStyle/>
-          <a:p>
             <a:pPr indent="0" marL="0">
               <a:buNone/>
             </a:pPr>
             <a:r>
-              <a:rPr lang="en-US" sz="1600" dirty="0">
-                <a:solidFill>
-                  <a:srgbClr val="FFFFFF"/>
-                </a:solidFill>
-                <a:latin typeface="Calibri" pitchFamily="34" charset="0"/>
-                <a:ea typeface="Calibri" pitchFamily="34" charset="-122"/>
-                <a:cs typeface="Calibri" pitchFamily="34" charset="-120"/>
-              </a:rPr>
-              <a:t>Claude votes in round 3</a:t>
-            </a:r>
-            <a:pPr indent="0" marL="0">
-              <a:buNone/>
-            </a:pPr>
-            <a:r>
-              <a:rPr lang="en-US" sz="1600" b="1" dirty="0">
-                <a:solidFill>
-                  <a:srgbClr val="F5A623"/>
-                </a:solidFill>
-                <a:latin typeface="Calibri" pitchFamily="34" charset="0"/>
-                <a:ea typeface="Calibri" pitchFamily="34" charset="-122"/>
-                <a:cs typeface="Calibri" pitchFamily="34" charset="-120"/>
-              </a:rPr>
-              <a:t>   →   </a:t>
-            </a:r>
-            <a:pPr indent="0" marL="0">
-              <a:buNone/>
-            </a:pPr>
-            <a:r>
-              <a:rPr lang="en-US" sz="1600" dirty="0">
-                <a:solidFill>
-                  <a:srgbClr val="C9D3DF"/>
-                </a:solidFill>
-                <a:latin typeface="Calibri" pitchFamily="34" charset="0"/>
-                <a:ea typeface="Calibri" pitchFamily="34" charset="-122"/>
-                <a:cs typeface="Calibri" pitchFamily="34" charset="-120"/>
-              </a:rPr>
-              <a:t>live Claude scoring in rounds 1 and 2</a:t>
-            </a:r>
-            <a:endParaRPr lang="en-US" sz="1600" dirty="0"/>
-          </a:p>
-        </p:txBody>
-      </p:sp>
-      <p:sp>
-        <p:nvSpPr>
-          <p:cNvPr id="12" name="Text 10"/>
-          <p:cNvSpPr/>
-          <p:nvPr/>
-        </p:nvSpPr>
-        <p:spPr>
-          <a:xfrm>
-            <a:off x="548640" y="3246120"/>
-            <a:ext cx="8046720" cy="1280160"/>
-          </a:xfrm>
-          <a:prstGeom prst="rect">
-            <a:avLst/>
-          </a:prstGeom>
-          <a:noFill/>
-          <a:ln/>
-        </p:spPr>
-        <p:txBody>
-          <a:bodyPr wrap="square" lIns="0" tIns="0" rIns="0" bIns="0" rtlCol="0" anchor="ctr"/>
-          <a:lstStyle/>
-          <a:p>
-            <a:pPr indent="0" marL="0">
-              <a:buNone/>
-            </a:pPr>
-            <a:r>
-              <a:rPr lang="en-US" sz="2600" b="1" dirty="0">
+              <a:rPr lang="en-US" sz="2800" b="1" dirty="0">
                 <a:solidFill>
                   <a:srgbClr val="F5A623"/>
                 </a:solidFill>
@@ -3968,14 +3837,14 @@
               </a:rPr>
               <a:t>Code owns safety.</a:t>
             </a:r>
-            <a:endParaRPr lang="en-US" sz="2600" dirty="0"/>
+            <a:endParaRPr lang="en-US" sz="2800" dirty="0"/>
           </a:p>
           <a:p>
             <a:pPr indent="0" marL="0">
               <a:buNone/>
             </a:pPr>
             <a:r>
-              <a:rPr lang="en-US" sz="2600" b="1" dirty="0">
+              <a:rPr lang="en-US" sz="2800" b="1" dirty="0">
                 <a:solidFill>
                   <a:srgbClr val="F5A623"/>
                 </a:solidFill>
@@ -3985,14 +3854,14 @@
               </a:rPr>
               <a:t>Agents own the trade-offs.</a:t>
             </a:r>
-            <a:endParaRPr lang="en-US" sz="2600" dirty="0"/>
+            <a:endParaRPr lang="en-US" sz="2800" dirty="0"/>
           </a:p>
           <a:p>
             <a:pPr indent="0" marL="0">
               <a:buNone/>
             </a:pPr>
             <a:r>
-              <a:rPr lang="en-US" sz="2600" b="1" dirty="0">
+              <a:rPr lang="en-US" sz="2800" b="1" dirty="0">
                 <a:solidFill>
                   <a:srgbClr val="F5A623"/>
                 </a:solidFill>
@@ -4002,19 +3871,19 @@
               </a:rPr>
               <a:t>Humans decide.</a:t>
             </a:r>
-            <a:endParaRPr lang="en-US" sz="2600" dirty="0"/>
-          </a:p>
-        </p:txBody>
-      </p:sp>
-      <p:sp>
-        <p:nvSpPr>
-          <p:cNvPr id="13" name="Text 11"/>
-          <p:cNvSpPr/>
-          <p:nvPr/>
-        </p:nvSpPr>
-        <p:spPr>
-          <a:xfrm>
-            <a:off x="548640" y="4617720"/>
+            <a:endParaRPr lang="en-US" sz="2800" dirty="0"/>
+          </a:p>
+        </p:txBody>
+      </p:sp>
+      <p:sp>
+        <p:nvSpPr>
+          <p:cNvPr id="10" name="Text 8"/>
+          <p:cNvSpPr/>
+          <p:nvPr/>
+        </p:nvSpPr>
+        <p:spPr>
+          <a:xfrm>
+            <a:off x="548640" y="4572000"/>
             <a:ext cx="8046720" cy="274320"/>
           </a:xfrm>
           <a:prstGeom prst="rect">
@@ -7964,8 +7833,8 @@
         </p:nvSpPr>
         <p:spPr>
           <a:xfrm>
-            <a:off x="4663440" y="3657600"/>
-            <a:ext cx="3931920" cy="731520"/>
+            <a:off x="4800600" y="3657600"/>
+            <a:ext cx="3657600" cy="731520"/>
           </a:xfrm>
           <a:prstGeom prst="rect">
             <a:avLst/>
@@ -7981,7 +7850,7 @@
               <a:buNone/>
             </a:pPr>
             <a:r>
-              <a:rPr lang="en-US" sz="1800" b="1" dirty="0">
+              <a:rPr lang="en-US" sz="1500" b="1" dirty="0">
                 <a:solidFill>
                   <a:srgbClr val="0F1B2D"/>
                 </a:solidFill>
@@ -7989,9 +7858,9 @@
                 <a:ea typeface="Calibri" pitchFamily="34" charset="-122"/>
                 <a:cs typeface="Calibri" pitchFamily="34" charset="-120"/>
               </a:rPr>
-              <a:t>Otherwise: deterministic fallback</a:t>
-            </a:r>
-            <a:endParaRPr lang="en-US" sz="1800" dirty="0"/>
+              <a:t>Otherwise: fallback, the cheapest plan that passes every rule</a:t>
+            </a:r>
+            <a:endParaRPr lang="en-US" sz="1500" dirty="0"/>
           </a:p>
         </p:txBody>
       </p:sp>

</xml_diff>